<commit_message>
Corriger trois défauts de sécurité relevés en revue et auditer les droits avec des comptes restreints
- Refus par défaut : un document sans diffusion déclarée est rejeté au lieu d'être diffusé à tous.
- L'assistant ne sert le classement d'experts qu'au rôle manager, comme la page Experts.
- LLM_EXTRACTION_ENABLED règle désormais l'extraction LLM par défaut à l'ingestion.
- Audit evaluation/access_audit.py : 66 questions, 5 architectures, 3 comptes restreints,
  990 réponses, 0 fuite. Rejeu de la campagne gelée : 0 différence sur 660 lignes.
- Tests ajoutés (106 cas) ; mémoire, présentation et fiches mis à jour.

Co-Authored-By: Claude Opus 5.5 <noreply@anthropic.com>
Claude-Session: https://claude.ai/code/session_01NrE4ofTo5apA1G8EiH67WD
</commit_message>
<xml_diff>
--- a/RAG/RAPPORT ET PRESENTATION/Presentation_PFE_Knowledge_Graph_LLM.pptx
+++ b/RAG/RAPPORT ET PRESENTATION/Presentation_PFE_Knowledge_Graph_LLM.pptx
@@ -126,7 +126,7 @@
   <p:extLst>
     <p:ext uri="{521415D9-36F7-43E2-AB2F-B90AF26B5E84}">
       <p14:sectionLst xmlns:p14="http://schemas.microsoft.com/office/powerpoint/2010/main">
-        <p14:section name="Introduction" id="{2b05bf1e-954d-9c12-b931-323610fdf785}">
+        <p14:section name="Introduction" id="{572c8cba-0dd6-aa0e-c9d7-3b2ab226c5ea}">
           <p14:sldIdLst>
             <p14:sldId id="256"/>
             <p14:sldId id="257"/>
@@ -134,7 +134,7 @@
             <p14:sldId id="259"/>
           </p14:sldIdLst>
         </p14:section>
-        <p14:section name="La solution" id="{adc71822-a050-fe25-bd94-996f31deaa87}">
+        <p14:section name="La solution" id="{927c2383-6b6f-e9f0-3cee-7a444136a107}">
           <p14:sldIdLst>
             <p14:sldId id="260"/>
             <p14:sldId id="261"/>
@@ -145,7 +145,7 @@
             <p14:sldId id="266"/>
           </p14:sldIdLst>
         </p14:section>
-        <p14:section name="Évaluation" id="{a300db8b-25d4-7ed5-f2c7-daae1111907f}">
+        <p14:section name="Évaluation" id="{d8877fbf-94c1-277f-edd2-1e87353a8599}">
           <p14:sldIdLst>
             <p14:sldId id="267"/>
             <p14:sldId id="268"/>
@@ -155,7 +155,7 @@
             <p14:sldId id="272"/>
           </p14:sldIdLst>
         </p14:section>
-        <p14:section name="Déploiement et conclusion" id="{66e82052-f440-4d98-8093-17eeaacff329}">
+        <p14:section name="Déploiement et conclusion" id="{aab82dfd-89ae-87ca-dc9d-c023f5db35f7}">
           <p14:sldIdLst>
             <p14:sldId id="273"/>
             <p14:sldId id="274"/>
@@ -4344,7 +4344,7 @@
           <a:p>
             <a:r>
               <a:rPr lang="en-US" dirty="0"/>
-              <a:t>La même question, « Quel est le RTO de CoreNova ? », donne deux résultats selon le compte. Le collaborateur n'est pas destinataire du plan de continuité : la plateforme s'abstient, sans même révéler que le document existe. L'ingénieur de la DSI obtient la valeur et sa source. C'est possible parce que la liste des documents autorisés est calculée avant la recherche et passée à chaque requête. Résultat mesuré : aucune fuite, quelle que soit la stratégie.</a:t>
+              <a:t>La même question, « Quel est le RTO de CoreNova ? », donne deux résultats selon le compte. Le collaborateur n'est pas destinataire du plan de continuité : la plateforme s'abstient, sans même révéler que le document existe. L'ingénieur de la DSI obtient la valeur et sa source. C'est possible parce que la liste des documents autorisés est calculée avant la recherche et passée à chaque requête. Un audit dédié rejoue les 66 questions avec trois comptes restreints et les cinq architectures : 990 réponses, aucune fuite. Et un document dont la diffusion n'est pas déclarée est refusé par défaut.</a:t>
             </a:r>
             <a:endParaRPr lang="en-US" dirty="0"/>
           </a:p>
@@ -18691,7 +18691,7 @@
                   <a:schemeClr val="accent2"/>
                 </a:solidFill>
               </a:rPr>
-              <a:t>0 fuite d'accès sur toutes les stratégies · mémo piégé mis en quarantaine dès l'ingestion · requêtes Cypher paramétrées</a:t>
+              <a:t>0 fuite sur 990 réponses rejouées avec 3 comptes restreints · mémo piégé en quarantaine · diffusion absente = refus</a:t>
             </a:r>
             <a:endParaRPr lang="en-US" sz="1500" dirty="0"/>
           </a:p>

</xml_diff>